<commit_message>
tailor.py: reject bullets that move a project to another employer
The first live run put the TaiwanPlus news-classification project under
聯合報系. profile/attribution.yaml lists each employer's signature terms;
tailor.py now rejects edits that use another employer's terms. Fixed the
華碩 CV and re-exported both PDFs with local PowerPoint fonts.

Co-Authored-By: Claude Opus 5.5 <noreply@anthropic.com>
</commit_message>
<xml_diff>
--- a/applications/2026-10-13_華碩電腦_Data-Scientist-AI/中文履歷_楊上瑋_華碩.pptx
+++ b/applications/2026-10-13_華碩電腦_Data-Scientist-AI/中文履歷_楊上瑋_華碩.pptx
@@ -15504,7 +15504,7 @@
                 <a:cs typeface="Lato"/>
                 <a:sym typeface="Lato"/>
               </a:rPr>
-              <a:t>競品分析與受眾策略：</a:t>
+              <a:t>新聞分類模型：</a:t>
             </a:r>
             <a:r>
               <a:rPr lang="zh-TW" altLang="en-US" sz="1000" i="0" u="none" strike="noStrike" cap="none" dirty="0">
@@ -15516,7 +15516,7 @@
                 <a:cs typeface="Lato"/>
                 <a:sym typeface="Lato"/>
               </a:rPr>
-              <a:t>對標</a:t>
+              <a:t>DistilBERT+Gemini信心度級聯，處理資料洩漏與標籤清洗，accuracy與macro-F1皆0.81。</a:t>
             </a:r>
             <a:r>
               <a:rPr lang="en-US" altLang="zh-TW" sz="1000" i="0" u="none" strike="noStrike" cap="none" dirty="0">
@@ -15528,7 +15528,7 @@
                 <a:cs typeface="Lato"/>
                 <a:sym typeface="Lato"/>
               </a:rPr>
-              <a:t>NHK World</a:t>
+              <a:t/>
             </a:r>
             <a:r>
               <a:rPr lang="zh-TW" altLang="en-US" sz="1000" i="0" u="none" strike="noStrike" cap="none" dirty="0">
@@ -15540,7 +15540,7 @@
                 <a:cs typeface="Lato"/>
                 <a:sym typeface="Lato"/>
               </a:rPr>
-              <a:t>、</a:t>
+              <a:t/>
             </a:r>
             <a:r>
               <a:rPr lang="en-US" altLang="zh-TW" sz="1000" i="0" u="none" strike="noStrike" cap="none" dirty="0">
@@ -15552,7 +15552,7 @@
                 <a:cs typeface="Lato"/>
                 <a:sym typeface="Lato"/>
               </a:rPr>
-              <a:t>CNA</a:t>
+              <a:t/>
             </a:r>
             <a:r>
               <a:rPr lang="zh-TW" altLang="en-US" sz="1000" i="0" u="none" strike="noStrike" cap="none" dirty="0">
@@ -15564,7 +15564,7 @@
                 <a:cs typeface="Lato"/>
                 <a:sym typeface="Lato"/>
               </a:rPr>
-              <a:t>、</a:t>
+              <a:t/>
             </a:r>
             <a:r>
               <a:rPr lang="en-US" altLang="zh-TW" sz="1000" i="0" u="none" strike="noStrike" cap="none" dirty="0">
@@ -15576,7 +15576,7 @@
                 <a:cs typeface="Lato"/>
                 <a:sym typeface="Lato"/>
               </a:rPr>
-              <a:t>Arirang</a:t>
+              <a:t/>
             </a:r>
             <a:r>
               <a:rPr lang="zh-TW" altLang="en-US" sz="1000" i="0" u="none" strike="noStrike" cap="none" dirty="0">
@@ -15588,7 +15588,7 @@
                 <a:cs typeface="Lato"/>
                 <a:sym typeface="Lato"/>
               </a:rPr>
-              <a:t>，發現流量規模雖小但互動品質全面領先，判定問題在受眾定位；據此鎖定約</a:t>
+              <a:t/>
             </a:r>
             <a:r>
               <a:rPr lang="en-US" altLang="zh-TW" sz="1000" i="0" u="none" strike="noStrike" cap="none" dirty="0">
@@ -15600,7 +15600,7 @@
                 <a:cs typeface="Lato"/>
                 <a:sym typeface="Lato"/>
               </a:rPr>
-              <a:t>17.6</a:t>
+              <a:t/>
             </a:r>
             <a:r>
               <a:rPr lang="zh-TW" altLang="en-US" sz="1000" i="0" u="none" strike="noStrike" cap="none" dirty="0">
@@ -15612,7 +15612,7 @@
                 <a:cs typeface="Lato"/>
                 <a:sym typeface="Lato"/>
               </a:rPr>
-              <a:t>萬名在台英語居民的藍海受眾，提出重新定位與通路策略。</a:t>
+              <a:t/>
             </a:r>
           </a:p>
           <a:p>
@@ -15917,7 +15917,7 @@
                 <a:cs typeface="Lato"/>
                 <a:sym typeface="Lato"/>
               </a:rPr>
-              <a:t>新聞分類：</a:t>
+              <a:t>流量分析與</a:t>
             </a:r>
             <a:r>
               <a:rPr lang="en-US" altLang="zh-TW" sz="1000" b="1" i="0" u="none" strike="noStrike" cap="none" dirty="0">
@@ -15929,7 +15929,7 @@
                 <a:cs typeface="Lato"/>
                 <a:sym typeface="Lato"/>
               </a:rPr>
-              <a:t/>
+              <a:t>AI</a:t>
             </a:r>
             <a:r>
               <a:rPr lang="zh-TW" altLang="en-US" sz="1000" b="1" i="0" u="none" strike="noStrike" cap="none" dirty="0">
@@ -15941,7 +15941,7 @@
                 <a:cs typeface="Lato"/>
                 <a:sym typeface="Lato"/>
               </a:rPr>
-              <a:t/>
+              <a:t>輔助選題：</a:t>
             </a:r>
             <a:r>
               <a:rPr lang="zh-TW" altLang="en-US" sz="1000" i="0" u="none" strike="noStrike" cap="none" dirty="0">
@@ -15953,7 +15953,7 @@
                 <a:cs typeface="Lato"/>
                 <a:sym typeface="Lato"/>
               </a:rPr>
-              <a:t>DistilBERT+Gemini信心度級聯，處理資料洩漏與標籤清洗，accuracy與macro-F1皆0.81。</a:t>
+              <a:t>定期向跨部門主管簡報網站流量與訂閱轉換指標並提出優化建議；整合</a:t>
             </a:r>
             <a:r>
               <a:rPr lang="en-US" altLang="zh-TW" sz="1000" i="0" u="none" strike="noStrike" cap="none" dirty="0">
@@ -15965,7 +15965,7 @@
                 <a:cs typeface="Lato"/>
                 <a:sym typeface="Lato"/>
               </a:rPr>
-              <a:t/>
+              <a:t>Google Trends API</a:t>
             </a:r>
             <a:r>
               <a:rPr lang="zh-TW" altLang="en-US" sz="1000" i="0" u="none" strike="noStrike" cap="none" dirty="0">
@@ -15977,7 +15977,7 @@
                 <a:cs typeface="Lato"/>
                 <a:sym typeface="Lato"/>
               </a:rPr>
-              <a:t/>
+              <a:t>與</a:t>
             </a:r>
             <a:r>
               <a:rPr lang="en-US" altLang="zh-TW" sz="1000" i="0" u="none" strike="noStrike" cap="none" dirty="0">
@@ -15989,7 +15989,7 @@
                 <a:cs typeface="Lato"/>
                 <a:sym typeface="Lato"/>
               </a:rPr>
-              <a:t/>
+              <a:t>AI</a:t>
             </a:r>
             <a:r>
               <a:rPr lang="zh-TW" altLang="en-US" sz="1000" i="0" u="none" strike="noStrike" cap="none" dirty="0">
@@ -16001,7 +16001,7 @@
                 <a:cs typeface="Lato"/>
                 <a:sym typeface="Lato"/>
               </a:rPr>
-              <a:t/>
+              <a:t>工具建立選題輔助流程</a:t>
             </a:r>
             <a:r>
               <a:rPr lang="zh-TW" altLang="en-US" sz="1000" dirty="0">
@@ -16013,7 +16013,7 @@
                 <a:cs typeface="Lato"/>
                 <a:sym typeface="Lato"/>
               </a:rPr>
-              <a:t/>
+              <a:t>。</a:t>
             </a:r>
             <a:endParaRPr lang="zh-TW" altLang="en-US" sz="1000" i="0" u="none" strike="noStrike" cap="none" dirty="0">
               <a:solidFill>

</xml_diff>

<commit_message>
Radar v2: target DE/DS, cv-judge review, JoBuzzer, DE/DS templates
- Scoring judges role fit by transferable evidence, not past titles; every
  DE/DS job gets a score (41 were bulk-filtered last week). Primary roles
  tailor at >=75; posted salary under NT$1M/yr -15; foreign/Japan +5.
- cv-judge subagent (Opus) reviews each tailored CV against the JD and the
  facts file (profile/judge_rubric.md); only PASS is reported as ready.
- scripts/cv_text.py dumps a CV with employer tags for the judge.
- candidate_facts: dbt layer at TaiwanPlus (cutover pending), DE pipelines;
  Airflow/Spark/Kafka listed as never-claim gaps.
- Template specs for the new DE/DS templates; fixed 中研院 name typo.
- JoBuzzer added as a source for foreign companies in Taipei/Tokyo.

Co-Authored-By: Claude Opus 5.5 <noreply@anthropic.com>
</commit_message>
<xml_diff>
--- a/applications/2026-10-13_華碩電腦_Data-Scientist-AI/中文履歷_楊上瑋_華碩.pptx
+++ b/applications/2026-10-13_華碩電腦_Data-Scientist-AI/中文履歷_楊上瑋_華碩.pptx
@@ -13646,7 +13646,7 @@
                 <a:cs typeface="Lato"/>
                 <a:sym typeface="Lato"/>
               </a:rPr>
-              <a:t>資料分析與視覺化</a:t>
+              <a:t>資料視覺化: Power BI, Tableau, GA4, Looker Studio</a:t>
             </a:r>
             <a:r>
               <a:rPr lang="en-US" altLang="zh-TW" sz="1000" dirty="0">
@@ -13658,7 +13658,7 @@
                 <a:cs typeface="Lato"/>
                 <a:sym typeface="Lato"/>
               </a:rPr>
-              <a:t>: Power BI, Tableau, GA4,  Looker Studio, Excel</a:t>
+              <a:t/>
             </a:r>
             <a:endParaRPr lang="en-US" sz="1000" b="0" i="0" u="none" strike="noStrike" cap="none" dirty="0">
               <a:solidFill>
@@ -13698,7 +13698,7 @@
                 <a:cs typeface="Lato"/>
                 <a:sym typeface="Lato"/>
               </a:rPr>
-              <a:t>程式語言</a:t>
+              <a:t>程式語言: Python, SQL, scikit-learn</a:t>
             </a:r>
             <a:r>
               <a:rPr lang="en-US" sz="1000" b="0" i="0" u="none" strike="noStrike" cap="none" dirty="0">
@@ -13710,7 +13710,7 @@
                 <a:cs typeface="Lato"/>
                 <a:sym typeface="Lato"/>
               </a:rPr>
-              <a:t>: Python, SQL, ETL</a:t>
+              <a:t/>
             </a:r>
             <a:endParaRPr dirty="0">
               <a:solidFill>
@@ -14569,7 +14569,7 @@
                 <a:cs typeface="Lato"/>
                 <a:sym typeface="Lato"/>
               </a:rPr>
-              <a:t>8年數據分析經驗，近年聚焦LLM應用：自建內部RAG助理(Vertex AI Search+Gemini)並設8項檢核評測層；DistilBERT+Gemini新聞分類F1達0.81；推薦排序使觀看成長5%。經濟學碩士，中英日三語。</a:t>
+              <a:t>8年跨媒體、新聞與藝術產業數據分析經驗，近年聚焦LLM應用：自建內部RAG助理(Vertex AI Search+Gemini，部署於Cloud Run)並設8項檢核評測層；DistilBERT+Gemini新聞分類macro-F1達0.81；推薦排序使觀看成長5%。經濟學碩士，已通過iPAS AI應用規劃師中級，中英日三語。</a:t>
             </a:r>
             <a:r>
               <a:rPr kumimoji="0" lang="zh-TW" altLang="en-US" sz="1000" b="0" i="0" u="none" strike="noStrike" kern="0" cap="none" spc="0" normalizeH="0" baseline="0" noProof="0" dirty="0">
@@ -15425,7 +15425,7 @@
                 <a:cs typeface="Lato"/>
                 <a:sym typeface="Lato"/>
               </a:rPr>
-              <a:t>Python→BigQuery→Vertex AI Search→Gemini，決策與檢索效率提升30%。</a:t>
+              <a:t>Python→BigQuery→Vertex AI Search→Gemini，以Streamlit部署於Cloud Run，決策與檢索效率提升30%。</a:t>
             </a:r>
             <a:r>
               <a:rPr lang="en-US" altLang="zh-TW" sz="1000" i="0" u="none" strike="noStrike" cap="none" dirty="0">
@@ -15516,7 +15516,7 @@
                 <a:cs typeface="Lato"/>
                 <a:sym typeface="Lato"/>
               </a:rPr>
-              <a:t>DistilBERT+Gemini信心度級聯，處理資料洩漏與標籤清洗，accuracy與macro-F1皆0.81。</a:t>
+              <a:t>DistilBERT+Gemini信心度級聯，處理資料洩漏與標籤清洗，準確率與macro-F1皆0.81。</a:t>
             </a:r>
             <a:r>
               <a:rPr lang="en-US" altLang="zh-TW" sz="1000" i="0" u="none" strike="noStrike" cap="none" dirty="0">
@@ -16877,7 +16877,7 @@
                 <a:latin typeface="微軟正黑體" panose="020B0604030504040204" pitchFamily="34" charset="-120"/>
                 <a:ea typeface="微軟正黑體" panose="020B0604030504040204" pitchFamily="34" charset="-120"/>
               </a:rPr>
-              <a:t>中央研究院人文社會研究中心</a:t>
+              <a:t>中研院人文社會科學研究中心</a:t>
             </a:r>
             <a:endParaRPr dirty="0">
               <a:solidFill>

</xml_diff>